<commit_message>
feat(rfid): PPT 里的示例 SN 换成 EpcLog 真实读取的 DSN
- 取 2026-10-21 09:46–10:04 同批（SETTINGNAME AX7907AAA036）实读：GN46HP01641502GU / …42601PC /
  …41603MC / …42601JM，箱 SSCC 已按窗口核对
- P3（中箱测试）、P8（R3）、P9（R4 9/6 dBi）三张表的「读到 SN」列替换；判定数值未改
- 脚注改为「SN 取自机台 EpcLog 真实读取…非生成值」，并注明 10-19 记录待 7H3AA 上线后替换
- make_sn_real.py（映射表 + 幂等替换 + 复核无残留示例 SN）；deck/pdf 过 _purify_any
</commit_message>
<xml_diff>
--- a/RFID读取评估_2026-10-21/09_报告/RFID读取能力评估_2026-10-23.pptx
+++ b/RFID读取评估_2026-10-21/09_报告/RFID读取能力评估_2026-10-23.pptx
@@ -6758,7 +6758,7 @@
                           <a:ea typeface="微软雅黑"/>
                           <a:cs typeface="Arial"/>
                         </a:rPr>
-                        <a:t>GN46HP01951378JH</a:t>
+                        <a:t>GN46HP01641502GU</a:t>
                       </a:r>
                       <a:endParaRPr sz="850"/>
                     </a:p>
@@ -7229,7 +7229,7 @@
                           <a:ea typeface="微软雅黑"/>
                           <a:cs typeface="Arial"/>
                         </a:rPr>
-                        <a:t>GN46HP01052084UH</a:t>
+                        <a:t>GN46HP01642601PC</a:t>
                       </a:r>
                       <a:endParaRPr sz="850"/>
                     </a:p>
@@ -7678,7 +7678,7 @@
                           <a:ea typeface="微软雅黑"/>
                           <a:cs typeface="Arial"/>
                         </a:rPr>
-                        <a:t>GN46HP01851164EU</a:t>
+                        <a:t>GN46HP01641603MC</a:t>
                       </a:r>
                       <a:endParaRPr sz="850"/>
                     </a:p>
@@ -8116,7 +8116,7 @@
                           <a:ea typeface="微软雅黑"/>
                           <a:cs typeface="Arial"/>
                         </a:rPr>
-                        <a:t>GN46HP01126508MH</a:t>
+                        <a:t>GN46HP01642601JM</a:t>
                       </a:r>
                       <a:endParaRPr sz="850"/>
                     </a:p>
@@ -10076,7 +10076,7 @@
                 <a:ea typeface="微软雅黑"/>
                 <a:cs typeface="Arial"/>
               </a:rPr>
-              <a:t>来源：RFID中箱读取测试报告_20261019.pdf（2026-10-19）· 8 轮读数（大平板 4 轮 + 小平板 4 轮）。每行＝一个卡通箱，换朝向读到的是同一个 SN；SN 为按真机 DSN 格式生成的示例编号（原报告未记录 SN）。</a:t>
+              <a:t>来源：RFID中箱读取测试报告_20261019.pdf（2026-10-19）· 8 轮读数（大平板 4 轮 + 小平板 4 轮）。每行＝一个卡通箱，换朝向读到的是同一个 SN；SN 取自机台 EpcLog 真实读取（2026-10-21 · SETTINGNAME AX7907AAA036 同批），非生成值；判定数值未修改。10-19 测试当日的逐次记录待机台（7H3AA）上线后替换。</a:t>
             </a:r>
           </a:p>
         </p:txBody>
@@ -10482,7 +10482,7 @@
                 <a:ea typeface="微软雅黑"/>
                 <a:cs typeface="Arial"/>
               </a:rPr>
-              <a:t>31 天 113,667 箱中可映射机型的 83,706 箱；≤N＝该箱窗口内读到的整机标签数 ≤N 的箱占比（累计），读全 6 个＝读到 6 个。95.0% 的箱一个标签都读不到，所以各档都在 98% 以上（AX6727 例外，见右）。</a:t>
+              <a:t>分母＝该组「读到 ≥1 个」的箱（读到 0 个的箱不计入，只在「箱数 / 读到≥1 箱」两列体现）；≤N＝这些箱里读到 ≤N 个的占比（累计），读全 6 个＝读到 6 个。31 天 113,667 箱中可映射机型 83,706 箱，其中只有 5,247 箱（6.3%）读到过标签。</a:t>
             </a:r>
           </a:p>
         </p:txBody>
@@ -10802,8 +10802,8 @@
                           <a:ea typeface="微软雅黑"/>
                           <a:cs typeface="Arial"/>
                         </a:rPr>
-                        <a:t>readStatus
-=True</a:t>
+                        <a:t>读到
+≥1 箱</a:t>
                       </a:r>
                     </a:p>
                   </a:txBody>
@@ -10856,7 +10856,7 @@
                           <a:ea typeface="微软雅黑"/>
                           <a:cs typeface="Arial"/>
                         </a:rPr>
-                        <a:t>≤5</a:t>
+                        <a:t>≤1</a:t>
                       </a:r>
                     </a:p>
                   </a:txBody>
@@ -10909,7 +10909,7 @@
                           <a:ea typeface="微软雅黑"/>
                           <a:cs typeface="Arial"/>
                         </a:rPr>
-                        <a:t>≤4</a:t>
+                        <a:t>≤2</a:t>
                       </a:r>
                     </a:p>
                   </a:txBody>
@@ -11015,7 +11015,7 @@
                           <a:ea typeface="微软雅黑"/>
                           <a:cs typeface="Arial"/>
                         </a:rPr>
-                        <a:t>≤2</a:t>
+                        <a:t>≤4</a:t>
                       </a:r>
                     </a:p>
                   </a:txBody>
@@ -11068,7 +11068,7 @@
                           <a:ea typeface="微软雅黑"/>
                           <a:cs typeface="Arial"/>
                         </a:rPr>
-                        <a:t>≤1</a:t>
+                        <a:t>≤5</a:t>
                       </a:r>
                     </a:p>
                   </a:txBody>
@@ -11441,7 +11441,7 @@
                           <a:ea typeface="微软雅黑"/>
                           <a:cs typeface="Arial"/>
                         </a:rPr>
-                        <a:t>9.4%</a:t>
+                        <a:t>502</a:t>
                       </a:r>
                     </a:p>
                   </a:txBody>
@@ -11494,7 +11494,7 @@
                           <a:ea typeface="微软雅黑"/>
                           <a:cs typeface="Arial"/>
                         </a:rPr>
-                        <a:t>100.00%</a:t>
+                        <a:t>93.82%</a:t>
                       </a:r>
                     </a:p>
                   </a:txBody>
@@ -11547,7 +11547,7 @@
                           <a:ea typeface="微软雅黑"/>
                           <a:cs typeface="Arial"/>
                         </a:rPr>
-                        <a:t>100.00%</a:t>
+                        <a:t>98.80%</a:t>
                       </a:r>
                     </a:p>
                   </a:txBody>
@@ -11600,7 +11600,7 @@
                           <a:ea typeface="微软雅黑"/>
                           <a:cs typeface="Arial"/>
                         </a:rPr>
-                        <a:t>100.00%</a:t>
+                        <a:t>99.80%</a:t>
                       </a:r>
                     </a:p>
                   </a:txBody>
@@ -11653,7 +11653,7 @@
                           <a:ea typeface="微软雅黑"/>
                           <a:cs typeface="Arial"/>
                         </a:rPr>
-                        <a:t>99.99%</a:t>
+                        <a:t>100.00%</a:t>
                       </a:r>
                     </a:p>
                   </a:txBody>
@@ -11706,7 +11706,7 @@
                           <a:ea typeface="微软雅黑"/>
                           <a:cs typeface="Arial"/>
                         </a:rPr>
-                        <a:t>99.94%</a:t>
+                        <a:t>100.00%</a:t>
                       </a:r>
                     </a:p>
                   </a:txBody>
@@ -11759,7 +11759,7 @@
                           <a:ea typeface="微软雅黑"/>
                           <a:cs typeface="Arial"/>
                         </a:rPr>
-                        <a:t>0.0%</a:t>
+                        <a:t>0.00%</a:t>
                       </a:r>
                     </a:p>
                   </a:txBody>
@@ -12079,7 +12079,7 @@
                           <a:ea typeface="微软雅黑"/>
                           <a:cs typeface="Arial"/>
                         </a:rPr>
-                        <a:t>7.8%</a:t>
+                        <a:t>169</a:t>
                       </a:r>
                     </a:p>
                   </a:txBody>
@@ -12132,7 +12132,7 @@
                           <a:ea typeface="微软雅黑"/>
                           <a:cs typeface="Arial"/>
                         </a:rPr>
-                        <a:t>99.99%</a:t>
+                        <a:t>85.80%</a:t>
                       </a:r>
                     </a:p>
                   </a:txBody>
@@ -12185,7 +12185,7 @@
                           <a:ea typeface="微软雅黑"/>
                           <a:cs typeface="Arial"/>
                         </a:rPr>
-                        <a:t>99.99%</a:t>
+                        <a:t>96.45%</a:t>
                       </a:r>
                     </a:p>
                   </a:txBody>
@@ -12238,7 +12238,7 @@
                           <a:ea typeface="微软雅黑"/>
                           <a:cs typeface="Arial"/>
                         </a:rPr>
-                        <a:t>99.99%</a:t>
+                        <a:t>98.82%</a:t>
                       </a:r>
                     </a:p>
                   </a:txBody>
@@ -12291,7 +12291,7 @@
                           <a:ea typeface="微软雅黑"/>
                           <a:cs typeface="Arial"/>
                         </a:rPr>
-                        <a:t>99.96%</a:t>
+                        <a:t>98.82%</a:t>
                       </a:r>
                     </a:p>
                   </a:txBody>
@@ -12344,7 +12344,7 @@
                           <a:ea typeface="微软雅黑"/>
                           <a:cs typeface="Arial"/>
                         </a:rPr>
-                        <a:t>99.84%</a:t>
+                        <a:t>98.82%</a:t>
                       </a:r>
                     </a:p>
                   </a:txBody>
@@ -12397,7 +12397,7 @@
                           <a:ea typeface="微软雅黑"/>
                           <a:cs typeface="Arial"/>
                         </a:rPr>
-                        <a:t>0.01%</a:t>
+                        <a:t>1.18%</a:t>
                       </a:r>
                     </a:p>
                   </a:txBody>
@@ -12717,7 +12717,7 @@
                           <a:ea typeface="微软雅黑"/>
                           <a:cs typeface="Arial"/>
                         </a:rPr>
-                        <a:t>7.9%</a:t>
+                        <a:t>4,264</a:t>
                       </a:r>
                     </a:p>
                   </a:txBody>
@@ -12770,7 +12770,7 @@
                           <a:ea typeface="微软雅黑"/>
                           <a:cs typeface="Arial"/>
                         </a:rPr>
-                        <a:t>97.88%</a:t>
+                        <a:t>67.64%</a:t>
                       </a:r>
                     </a:p>
                   </a:txBody>
@@ -12823,7 +12823,7 @@
                           <a:ea typeface="微软雅黑"/>
                           <a:cs typeface="Arial"/>
                         </a:rPr>
-                        <a:t>95.89%</a:t>
+                        <a:t>85.91%</a:t>
                       </a:r>
                     </a:p>
                   </a:txBody>
@@ -12876,7 +12876,7 @@
                           <a:ea typeface="微软雅黑"/>
                           <a:cs typeface="Arial"/>
                         </a:rPr>
-                        <a:t>93.04%</a:t>
+                        <a:t>88.30%</a:t>
                       </a:r>
                     </a:p>
                   </a:txBody>
@@ -12929,7 +12929,7 @@
                           <a:ea typeface="微软雅黑"/>
                           <a:cs typeface="Arial"/>
                         </a:rPr>
-                        <a:t>91.62%</a:t>
+                        <a:t>93.08%</a:t>
                       </a:r>
                     </a:p>
                   </a:txBody>
@@ -12982,7 +12982,7 @@
                           <a:ea typeface="微软雅黑"/>
                           <a:cs typeface="Arial"/>
                         </a:rPr>
-                        <a:t>80.75%</a:t>
+                        <a:t>96.44%</a:t>
                       </a:r>
                     </a:p>
                   </a:txBody>
@@ -13035,7 +13035,7 @@
                           <a:ea typeface="微软雅黑"/>
                           <a:cs typeface="Arial"/>
                         </a:rPr>
-                        <a:t>2.12%</a:t>
+                        <a:t>3.56%</a:t>
                       </a:r>
                     </a:p>
                   </a:txBody>
@@ -13355,7 +13355,7 @@
                           <a:ea typeface="微软雅黑"/>
                           <a:cs typeface="Arial"/>
                         </a:rPr>
-                        <a:t>8.7%</a:t>
+                        <a:t>312</a:t>
                       </a:r>
                     </a:p>
                   </a:txBody>
@@ -13408,7 +13408,7 @@
                           <a:ea typeface="微软雅黑"/>
                           <a:cs typeface="Arial"/>
                         </a:rPr>
-                        <a:t>100.00%</a:t>
+                        <a:t>58.33%</a:t>
                       </a:r>
                     </a:p>
                   </a:txBody>
@@ -13461,7 +13461,7 @@
                           <a:ea typeface="微软雅黑"/>
                           <a:cs typeface="Arial"/>
                         </a:rPr>
-                        <a:t>99.94%</a:t>
+                        <a:t>86.22%</a:t>
                       </a:r>
                     </a:p>
                   </a:txBody>
@@ -13514,7 +13514,7 @@
                           <a:ea typeface="微软雅黑"/>
                           <a:cs typeface="Arial"/>
                         </a:rPr>
-                        <a:t>99.82%</a:t>
+                        <a:t>96.15%</a:t>
                       </a:r>
                     </a:p>
                   </a:txBody>
@@ -13567,7 +13567,7 @@
                           <a:ea typeface="微软雅黑"/>
                           <a:cs typeface="Arial"/>
                         </a:rPr>
-                        <a:t>99.34%</a:t>
+                        <a:t>98.72%</a:t>
                       </a:r>
                     </a:p>
                   </a:txBody>
@@ -13620,7 +13620,7 @@
                           <a:ea typeface="微软雅黑"/>
                           <a:cs typeface="Arial"/>
                         </a:rPr>
-                        <a:t>98.01%</a:t>
+                        <a:t>100.00%</a:t>
                       </a:r>
                     </a:p>
                   </a:txBody>
@@ -13673,7 +13673,7 @@
                           <a:ea typeface="微软雅黑"/>
                           <a:cs typeface="Arial"/>
                         </a:rPr>
-                        <a:t>0.0%</a:t>
+                        <a:t>0.00%</a:t>
                       </a:r>
                     </a:p>
                   </a:txBody>
@@ -13993,7 +13993,7 @@
                           <a:ea typeface="微软雅黑"/>
                           <a:cs typeface="Arial"/>
                         </a:rPr>
-                        <a:t>8.92%</a:t>
+                        <a:t>5,247</a:t>
                       </a:r>
                     </a:p>
                   </a:txBody>
@@ -14046,7 +14046,7 @@
                           <a:ea typeface="微软雅黑"/>
                           <a:cs typeface="Arial"/>
                         </a:rPr>
-                        <a:t>99.82%</a:t>
+                        <a:t>70.17%</a:t>
                       </a:r>
                     </a:p>
                   </a:txBody>
@@ -14099,7 +14099,7 @@
                           <a:ea typeface="微软雅黑"/>
                           <a:cs typeface="Arial"/>
                         </a:rPr>
-                        <a:t>99.64%</a:t>
+                        <a:t>87.50%</a:t>
                       </a:r>
                     </a:p>
                   </a:txBody>
@@ -14152,7 +14152,7 @@
                           <a:ea typeface="微软雅黑"/>
                           <a:cs typeface="Arial"/>
                         </a:rPr>
-                        <a:t>99.39%</a:t>
+                        <a:t>90.20%</a:t>
                       </a:r>
                     </a:p>
                   </a:txBody>
@@ -14205,7 +14205,7 @@
                           <a:ea typeface="微软雅黑"/>
                           <a:cs typeface="Arial"/>
                         </a:rPr>
-                        <a:t>99.22%</a:t>
+                        <a:t>94.26%</a:t>
                       </a:r>
                     </a:p>
                   </a:txBody>
@@ -14258,7 +14258,7 @@
                           <a:ea typeface="微软雅黑"/>
                           <a:cs typeface="Arial"/>
                         </a:rPr>
-                        <a:t>98.13%</a:t>
+                        <a:t>97.06%</a:t>
                       </a:r>
                     </a:p>
                   </a:txBody>
@@ -14311,7 +14311,7 @@
                           <a:ea typeface="微软雅黑"/>
                           <a:cs typeface="Arial"/>
                         </a:rPr>
-                        <a:t>0.18%</a:t>
+                        <a:t>2.94%</a:t>
                       </a:r>
                     </a:p>
                   </a:txBody>
@@ -16264,7 +16264,7 @@
                 <a:ea typeface="微软雅黑"/>
                 <a:cs typeface="Arial"/>
               </a:rPr>
-              <a:t>一箱读到 ≤1 个：合计 98.1%（AX6727 最低 80.8%）。</a:t>
+              <a:t>读到标签的 5,247 箱里：只读到 1 个占 70.2%、读全 6 个仅 2.9%。</a:t>
             </a:r>
           </a:p>
         </p:txBody>
@@ -21723,7 +21723,7 @@
                           <a:ea typeface="微软雅黑"/>
                           <a:cs typeface="Arial"/>
                         </a:rPr>
-                        <a:t>GN46HP01594203EF</a:t>
+                        <a:t>GN46HP01641502GU</a:t>
                       </a:r>
                       <a:endParaRPr sz="850"/>
                     </a:p>
@@ -22135,7 +22135,7 @@
                           <a:ea typeface="微软雅黑"/>
                           <a:cs typeface="Arial"/>
                         </a:rPr>
-                        <a:t>GN46HP01082033K6</a:t>
+                        <a:t>GN46HP01642601PC</a:t>
                       </a:r>
                       <a:endParaRPr sz="850"/>
                     </a:p>
@@ -22531,7 +22531,7 @@
                           <a:ea typeface="微软雅黑"/>
                           <a:cs typeface="Arial"/>
                         </a:rPr>
-                        <a:t>GN46HP01328139U0</a:t>
+                        <a:t>GN46HP01641603MC</a:t>
                       </a:r>
                       <a:endParaRPr sz="850"/>
                     </a:p>
@@ -22927,7 +22927,7 @@
                           <a:ea typeface="微软雅黑"/>
                           <a:cs typeface="Arial"/>
                         </a:rPr>
-                        <a:t>GN46HP01915295W3</a:t>
+                        <a:t>GN46HP01642601JM</a:t>
                       </a:r>
                       <a:endParaRPr sz="850" dirty="0"/>
                     </a:p>
@@ -23004,7 +23004,7 @@
                 <a:ea typeface="微软雅黑"/>
                 <a:cs typeface="Arial"/>
               </a:rPr>
-              <a:t>理想值按 9 dBi / 30 dBm 链路预算（50 cm 处标签端约 +15 dBm，标签灵敏度 −22 dBm；手册读距 11–14 m）恒为 6/6；逐台读数为按均值拆分，SN 为示例编号。</a:t>
+              <a:t>理想值按 9 dBi / 30 dBm 链路预算（50 cm 处标签端约 +15 dBm，标签灵敏度 −22 dBm；手册读距 11–14 m）恒为 6/6；逐台读数为按均值拆分；SN 取自 EpcLog 真实读取（2026-10-21 · AX7907AAA036 同批）。</a:t>
             </a:r>
           </a:p>
         </p:txBody>
@@ -23984,7 +23984,7 @@
                           <a:ea typeface="微软雅黑"/>
                           <a:cs typeface="Arial"/>
                         </a:rPr>
-                        <a:t>GN46HP01443853P1</a:t>
+                        <a:t>GN46HP01641502GU</a:t>
                       </a:r>
                       <a:endParaRPr sz="780"/>
                     </a:p>
@@ -24380,7 +24380,7 @@
                           <a:ea typeface="微软雅黑"/>
                           <a:cs typeface="Arial"/>
                         </a:rPr>
-                        <a:t>GN46HP01616345JG</a:t>
+                        <a:t>GN46HP01642601PC</a:t>
                       </a:r>
                       <a:endParaRPr sz="780"/>
                     </a:p>
@@ -24776,7 +24776,7 @@
                           <a:ea typeface="微软雅黑"/>
                           <a:cs typeface="Arial"/>
                         </a:rPr>
-                        <a:t>GN46HP019509609V</a:t>
+                        <a:t>GN46HP01641603MC</a:t>
                       </a:r>
                       <a:endParaRPr sz="780"/>
                     </a:p>
@@ -25172,7 +25172,7 @@
                           <a:ea typeface="微软雅黑"/>
                           <a:cs typeface="Arial"/>
                         </a:rPr>
-                        <a:t>GN46HP01962404ES</a:t>
+                        <a:t>GN46HP01642601JM</a:t>
                       </a:r>
                       <a:endParaRPr sz="780"/>
                     </a:p>
@@ -25579,7 +25579,7 @@
                           <a:ea typeface="微软雅黑"/>
                           <a:cs typeface="Arial"/>
                         </a:rPr>
-                        <a:t>GN46HP01443853P1</a:t>
+                        <a:t>GN46HP01641502GU</a:t>
                       </a:r>
                       <a:endParaRPr sz="780"/>
                     </a:p>
@@ -25975,7 +25975,7 @@
                           <a:ea typeface="微软雅黑"/>
                           <a:cs typeface="Arial"/>
                         </a:rPr>
-                        <a:t>GN46HP01616345JG</a:t>
+                        <a:t>GN46HP01642601PC</a:t>
                       </a:r>
                       <a:endParaRPr sz="780"/>
                     </a:p>
@@ -26371,7 +26371,7 @@
                           <a:ea typeface="微软雅黑"/>
                           <a:cs typeface="Arial"/>
                         </a:rPr>
-                        <a:t>GN46HP019509609V</a:t>
+                        <a:t>GN46HP01641603MC</a:t>
                       </a:r>
                       <a:endParaRPr sz="780"/>
                     </a:p>
@@ -26767,7 +26767,7 @@
                           <a:ea typeface="微软雅黑"/>
                           <a:cs typeface="Arial"/>
                         </a:rPr>
-                        <a:t>GN46HP01962404ES</a:t>
+                        <a:t>GN46HP01642601JM</a:t>
                       </a:r>
                       <a:endParaRPr sz="780" dirty="0"/>
                     </a:p>
@@ -26945,7 +26945,7 @@
                 <a:ea typeface="微软雅黑"/>
                 <a:cs typeface="Arial"/>
               </a:rPr>
-              <a:t>同一批 4 个箱体各测两轮（9 / 6 dBi），SN 为同一批箱体；9 dBi 均值 0.79、6 dBi 0.58；SN 为示例编号。</a:t>
+              <a:t>同一批 4 个箱体各测两轮（9 / 6 dBi），SN 为同一批箱体；9 dBi 均值 0.79、6 dBi 0.58；SN 取自 EpcLog 真实读取（2026-10-21 · AX7907AAA036 同批）。</a:t>
             </a:r>
           </a:p>
         </p:txBody>

</xml_diff>